<commit_message>
Kommentare Thomas größtenteils eingearbeitet
</commit_message>
<xml_diff>
--- a/figures/IPEC_Figures_PowerPoint.pptx
+++ b/figures/IPEC_Figures_PowerPoint.pptx
@@ -5,12 +5,13 @@
     <p:sldMasterId id="2147483648" r:id="rId1"/>
   </p:sldMasterIdLst>
   <p:notesMasterIdLst>
-    <p:notesMasterId r:id="rId5"/>
+    <p:notesMasterId r:id="rId6"/>
   </p:notesMasterIdLst>
   <p:sldIdLst>
     <p:sldId id="610" r:id="rId2"/>
     <p:sldId id="621" r:id="rId3"/>
     <p:sldId id="622" r:id="rId4"/>
+    <p:sldId id="623" r:id="rId5"/>
   </p:sldIdLst>
   <p:sldSz cx="12192000" cy="6858000"/>
   <p:notesSz cx="6858000" cy="9144000"/>
@@ -109,6 +110,11 @@
       </a:defRPr>
     </a:lvl9pPr>
   </p:defaultTextStyle>
+  <p:extLst>
+    <p:ext uri="{EFAFB233-063F-42B5-8137-9DF3F51BA10A}">
+      <p15:sldGuideLst xmlns:p15="http://schemas.microsoft.com/office/powerpoint/2012/main"/>
+    </p:ext>
+  </p:extLst>
 </p:presentation>
 </file>
 
@@ -194,7 +200,7 @@
           <a:p>
             <a:fld id="{8BA047FC-F2F2-4B28-B76C-DEA75FAA1BBF}" type="datetimeFigureOut">
               <a:rPr lang="de-DE" smtClean="0"/>
-              <a:t>19.02.2026</a:t>
+              <a:t>15.03.2026</a:t>
             </a:fld>
             <a:endParaRPr lang="de-DE"/>
           </a:p>
@@ -722,7 +728,7 @@
           <a:p>
             <a:fld id="{B0B8CC02-5EFB-42DA-BC90-4C89E884E644}" type="datetimeFigureOut">
               <a:rPr lang="de-DE" smtClean="0"/>
-              <a:t>19.02.2026</a:t>
+              <a:t>15.03.2026</a:t>
             </a:fld>
             <a:endParaRPr lang="de-DE"/>
           </a:p>
@@ -920,7 +926,7 @@
           <a:p>
             <a:fld id="{B0B8CC02-5EFB-42DA-BC90-4C89E884E644}" type="datetimeFigureOut">
               <a:rPr lang="de-DE" smtClean="0"/>
-              <a:t>19.02.2026</a:t>
+              <a:t>15.03.2026</a:t>
             </a:fld>
             <a:endParaRPr lang="de-DE"/>
           </a:p>
@@ -1128,7 +1134,7 @@
           <a:p>
             <a:fld id="{B0B8CC02-5EFB-42DA-BC90-4C89E884E644}" type="datetimeFigureOut">
               <a:rPr lang="de-DE" smtClean="0"/>
-              <a:t>19.02.2026</a:t>
+              <a:t>15.03.2026</a:t>
             </a:fld>
             <a:endParaRPr lang="de-DE"/>
           </a:p>
@@ -1634,7 +1640,7 @@
           <a:p>
             <a:fld id="{B0B8CC02-5EFB-42DA-BC90-4C89E884E644}" type="datetimeFigureOut">
               <a:rPr lang="de-DE" smtClean="0"/>
-              <a:t>19.02.2026</a:t>
+              <a:t>15.03.2026</a:t>
             </a:fld>
             <a:endParaRPr lang="de-DE"/>
           </a:p>
@@ -1909,7 +1915,7 @@
           <a:p>
             <a:fld id="{B0B8CC02-5EFB-42DA-BC90-4C89E884E644}" type="datetimeFigureOut">
               <a:rPr lang="de-DE" smtClean="0"/>
-              <a:t>19.02.2026</a:t>
+              <a:t>15.03.2026</a:t>
             </a:fld>
             <a:endParaRPr lang="de-DE"/>
           </a:p>
@@ -2174,7 +2180,7 @@
           <a:p>
             <a:fld id="{B0B8CC02-5EFB-42DA-BC90-4C89E884E644}" type="datetimeFigureOut">
               <a:rPr lang="de-DE" smtClean="0"/>
-              <a:t>19.02.2026</a:t>
+              <a:t>15.03.2026</a:t>
             </a:fld>
             <a:endParaRPr lang="de-DE"/>
           </a:p>
@@ -2586,7 +2592,7 @@
           <a:p>
             <a:fld id="{B0B8CC02-5EFB-42DA-BC90-4C89E884E644}" type="datetimeFigureOut">
               <a:rPr lang="de-DE" smtClean="0"/>
-              <a:t>19.02.2026</a:t>
+              <a:t>15.03.2026</a:t>
             </a:fld>
             <a:endParaRPr lang="de-DE"/>
           </a:p>
@@ -2727,7 +2733,7 @@
           <a:p>
             <a:fld id="{B0B8CC02-5EFB-42DA-BC90-4C89E884E644}" type="datetimeFigureOut">
               <a:rPr lang="de-DE" smtClean="0"/>
-              <a:t>19.02.2026</a:t>
+              <a:t>15.03.2026</a:t>
             </a:fld>
             <a:endParaRPr lang="de-DE"/>
           </a:p>
@@ -2840,7 +2846,7 @@
           <a:p>
             <a:fld id="{B0B8CC02-5EFB-42DA-BC90-4C89E884E644}" type="datetimeFigureOut">
               <a:rPr lang="de-DE" smtClean="0"/>
-              <a:t>19.02.2026</a:t>
+              <a:t>15.03.2026</a:t>
             </a:fld>
             <a:endParaRPr lang="de-DE"/>
           </a:p>
@@ -3151,7 +3157,7 @@
           <a:p>
             <a:fld id="{B0B8CC02-5EFB-42DA-BC90-4C89E884E644}" type="datetimeFigureOut">
               <a:rPr lang="de-DE" smtClean="0"/>
-              <a:t>19.02.2026</a:t>
+              <a:t>15.03.2026</a:t>
             </a:fld>
             <a:endParaRPr lang="de-DE"/>
           </a:p>
@@ -3439,7 +3445,7 @@
           <a:p>
             <a:fld id="{B0B8CC02-5EFB-42DA-BC90-4C89E884E644}" type="datetimeFigureOut">
               <a:rPr lang="de-DE" smtClean="0"/>
-              <a:t>19.02.2026</a:t>
+              <a:t>15.03.2026</a:t>
             </a:fld>
             <a:endParaRPr lang="de-DE"/>
           </a:p>
@@ -3680,7 +3686,7 @@
           <a:p>
             <a:fld id="{B0B8CC02-5EFB-42DA-BC90-4C89E884E644}" type="datetimeFigureOut">
               <a:rPr lang="de-DE" smtClean="0"/>
-              <a:t>19.02.2026</a:t>
+              <a:t>15.03.2026</a:t>
             </a:fld>
             <a:endParaRPr lang="de-DE"/>
           </a:p>
@@ -14629,6 +14635,2124 @@
     <p:extLst>
       <p:ext uri="{BB962C8B-B14F-4D97-AF65-F5344CB8AC3E}">
         <p14:creationId xmlns:p14="http://schemas.microsoft.com/office/powerpoint/2010/main" val="2789225459"/>
+      </p:ext>
+    </p:extLst>
+  </p:cSld>
+  <p:clrMapOvr>
+    <a:masterClrMapping/>
+  </p:clrMapOvr>
+</p:sld>
+</file>
+
+<file path=ppt/slides/slide4.xml><?xml version="1.0" encoding="utf-8"?>
+<p:sld xmlns:a="http://schemas.openxmlformats.org/drawingml/2006/main" xmlns:r="http://schemas.openxmlformats.org/officeDocument/2006/relationships" xmlns:p="http://schemas.openxmlformats.org/presentationml/2006/main">
+  <p:cSld>
+    <p:spTree>
+      <p:nvGrpSpPr>
+        <p:cNvPr id="1" name="">
+          <a:extLst>
+            <a:ext uri="{FF2B5EF4-FFF2-40B4-BE49-F238E27FC236}">
+              <a16:creationId xmlns:a16="http://schemas.microsoft.com/office/drawing/2014/main" id="{F3E63F2B-DB60-9585-3548-1445B5353347}"/>
+            </a:ext>
+          </a:extLst>
+        </p:cNvPr>
+        <p:cNvGrpSpPr/>
+        <p:nvPr/>
+      </p:nvGrpSpPr>
+      <p:grpSpPr>
+        <a:xfrm>
+          <a:off x="0" y="0"/>
+          <a:ext cx="0" cy="0"/>
+          <a:chOff x="0" y="0"/>
+          <a:chExt cx="0" cy="0"/>
+        </a:xfrm>
+      </p:grpSpPr>
+      <p:graphicFrame>
+        <p:nvGraphicFramePr>
+          <p:cNvPr id="28" name="Tabelle 27">
+            <a:extLst>
+              <a:ext uri="{FF2B5EF4-FFF2-40B4-BE49-F238E27FC236}">
+                <a16:creationId xmlns:a16="http://schemas.microsoft.com/office/drawing/2014/main" id="{551F5C7D-75F9-80E9-F55F-8BD0C4B5E135}"/>
+              </a:ext>
+            </a:extLst>
+          </p:cNvPr>
+          <p:cNvGraphicFramePr>
+            <a:graphicFrameLocks noGrp="1"/>
+          </p:cNvGraphicFramePr>
+          <p:nvPr/>
+        </p:nvGraphicFramePr>
+        <p:xfrm>
+          <a:off x="-812777" y="5868550"/>
+          <a:ext cx="11208840" cy="640080"/>
+        </p:xfrm>
+        <a:graphic>
+          <a:graphicData uri="http://schemas.openxmlformats.org/drawingml/2006/table">
+            <a:tbl>
+              <a:tblPr firstRow="1" bandRow="1">
+                <a:tableStyleId>{2D5ABB26-0587-4C30-8999-92F81FD0307C}</a:tableStyleId>
+              </a:tblPr>
+              <a:tblGrid>
+                <a:gridCol w="934070">
+                  <a:extLst>
+                    <a:ext uri="{9D8B030D-6E8A-4147-A177-3AD203B41FA5}">
+                      <a16:colId xmlns:a16="http://schemas.microsoft.com/office/drawing/2014/main" val="2674426793"/>
+                    </a:ext>
+                  </a:extLst>
+                </a:gridCol>
+                <a:gridCol w="934070">
+                  <a:extLst>
+                    <a:ext uri="{9D8B030D-6E8A-4147-A177-3AD203B41FA5}">
+                      <a16:colId xmlns:a16="http://schemas.microsoft.com/office/drawing/2014/main" val="3572661540"/>
+                    </a:ext>
+                  </a:extLst>
+                </a:gridCol>
+                <a:gridCol w="934070">
+                  <a:extLst>
+                    <a:ext uri="{9D8B030D-6E8A-4147-A177-3AD203B41FA5}">
+                      <a16:colId xmlns:a16="http://schemas.microsoft.com/office/drawing/2014/main" val="3961166950"/>
+                    </a:ext>
+                  </a:extLst>
+                </a:gridCol>
+                <a:gridCol w="934070">
+                  <a:extLst>
+                    <a:ext uri="{9D8B030D-6E8A-4147-A177-3AD203B41FA5}">
+                      <a16:colId xmlns:a16="http://schemas.microsoft.com/office/drawing/2014/main" val="2768585121"/>
+                    </a:ext>
+                  </a:extLst>
+                </a:gridCol>
+                <a:gridCol w="934070">
+                  <a:extLst>
+                    <a:ext uri="{9D8B030D-6E8A-4147-A177-3AD203B41FA5}">
+                      <a16:colId xmlns:a16="http://schemas.microsoft.com/office/drawing/2014/main" val="1351681767"/>
+                    </a:ext>
+                  </a:extLst>
+                </a:gridCol>
+                <a:gridCol w="934070">
+                  <a:extLst>
+                    <a:ext uri="{9D8B030D-6E8A-4147-A177-3AD203B41FA5}">
+                      <a16:colId xmlns:a16="http://schemas.microsoft.com/office/drawing/2014/main" val="3656942"/>
+                    </a:ext>
+                  </a:extLst>
+                </a:gridCol>
+                <a:gridCol w="934070">
+                  <a:extLst>
+                    <a:ext uri="{9D8B030D-6E8A-4147-A177-3AD203B41FA5}">
+                      <a16:colId xmlns:a16="http://schemas.microsoft.com/office/drawing/2014/main" val="684801856"/>
+                    </a:ext>
+                  </a:extLst>
+                </a:gridCol>
+                <a:gridCol w="934070">
+                  <a:extLst>
+                    <a:ext uri="{9D8B030D-6E8A-4147-A177-3AD203B41FA5}">
+                      <a16:colId xmlns:a16="http://schemas.microsoft.com/office/drawing/2014/main" val="2683172096"/>
+                    </a:ext>
+                  </a:extLst>
+                </a:gridCol>
+                <a:gridCol w="934070">
+                  <a:extLst>
+                    <a:ext uri="{9D8B030D-6E8A-4147-A177-3AD203B41FA5}">
+                      <a16:colId xmlns:a16="http://schemas.microsoft.com/office/drawing/2014/main" val="2798623327"/>
+                    </a:ext>
+                  </a:extLst>
+                </a:gridCol>
+                <a:gridCol w="934070">
+                  <a:extLst>
+                    <a:ext uri="{9D8B030D-6E8A-4147-A177-3AD203B41FA5}">
+                      <a16:colId xmlns:a16="http://schemas.microsoft.com/office/drawing/2014/main" val="1580858874"/>
+                    </a:ext>
+                  </a:extLst>
+                </a:gridCol>
+                <a:gridCol w="934070">
+                  <a:extLst>
+                    <a:ext uri="{9D8B030D-6E8A-4147-A177-3AD203B41FA5}">
+                      <a16:colId xmlns:a16="http://schemas.microsoft.com/office/drawing/2014/main" val="259720998"/>
+                    </a:ext>
+                  </a:extLst>
+                </a:gridCol>
+                <a:gridCol w="934070">
+                  <a:extLst>
+                    <a:ext uri="{9D8B030D-6E8A-4147-A177-3AD203B41FA5}">
+                      <a16:colId xmlns:a16="http://schemas.microsoft.com/office/drawing/2014/main" val="3917417724"/>
+                    </a:ext>
+                  </a:extLst>
+                </a:gridCol>
+              </a:tblGrid>
+              <a:tr h="163560">
+                <a:tc>
+                  <a:txBody>
+                    <a:bodyPr/>
+                    <a:lstStyle/>
+                    <a:p>
+                      <a:endParaRPr lang="de-DE" sz="500" dirty="0"/>
+                    </a:p>
+                  </a:txBody>
+                  <a:tcPr>
+                    <a:lnL w="12700" cap="flat" cmpd="sng" algn="ctr">
+                      <a:noFill/>
+                      <a:prstDash val="solid"/>
+                      <a:round/>
+                      <a:headEnd type="none" w="med" len="med"/>
+                      <a:tailEnd type="none" w="med" len="med"/>
+                    </a:lnL>
+                    <a:lnR w="12700" cap="flat" cmpd="sng" algn="ctr">
+                      <a:solidFill>
+                        <a:schemeClr val="tx1"/>
+                      </a:solidFill>
+                      <a:prstDash val="solid"/>
+                      <a:round/>
+                      <a:headEnd type="none" w="med" len="med"/>
+                      <a:tailEnd type="none" w="med" len="med"/>
+                    </a:lnR>
+                    <a:lnT w="12700" cap="flat" cmpd="sng" algn="ctr">
+                      <a:noFill/>
+                      <a:prstDash val="solid"/>
+                      <a:round/>
+                      <a:headEnd type="none" w="med" len="med"/>
+                      <a:tailEnd type="none" w="med" len="med"/>
+                    </a:lnT>
+                    <a:lnB w="12700" cap="flat" cmpd="sng" algn="ctr">
+                      <a:noFill/>
+                      <a:prstDash val="solid"/>
+                      <a:round/>
+                      <a:headEnd type="none" w="med" len="med"/>
+                      <a:tailEnd type="none" w="med" len="med"/>
+                    </a:lnB>
+                    <a:lnTlToBr w="12700" cmpd="sng">
+                      <a:noFill/>
+                      <a:prstDash val="solid"/>
+                    </a:lnTlToBr>
+                    <a:lnBlToTr w="12700" cmpd="sng">
+                      <a:noFill/>
+                      <a:prstDash val="solid"/>
+                    </a:lnBlToTr>
+                  </a:tcPr>
+                </a:tc>
+                <a:tc>
+                  <a:txBody>
+                    <a:bodyPr/>
+                    <a:lstStyle/>
+                    <a:p>
+                      <a:endParaRPr lang="de-DE" sz="500" dirty="0"/>
+                    </a:p>
+                  </a:txBody>
+                  <a:tcPr>
+                    <a:lnL w="12700" cap="flat" cmpd="sng" algn="ctr">
+                      <a:solidFill>
+                        <a:schemeClr val="tx1"/>
+                      </a:solidFill>
+                      <a:prstDash val="solid"/>
+                      <a:round/>
+                      <a:headEnd type="none" w="med" len="med"/>
+                      <a:tailEnd type="none" w="med" len="med"/>
+                    </a:lnL>
+                    <a:lnR w="12700" cap="flat" cmpd="sng" algn="ctr">
+                      <a:noFill/>
+                      <a:prstDash val="solid"/>
+                      <a:round/>
+                      <a:headEnd type="none" w="med" len="med"/>
+                      <a:tailEnd type="none" w="med" len="med"/>
+                    </a:lnR>
+                    <a:lnT w="12700" cap="flat" cmpd="sng" algn="ctr">
+                      <a:noFill/>
+                      <a:prstDash val="solid"/>
+                      <a:round/>
+                      <a:headEnd type="none" w="med" len="med"/>
+                      <a:tailEnd type="none" w="med" len="med"/>
+                    </a:lnT>
+                    <a:lnB w="12700" cap="flat" cmpd="sng" algn="ctr">
+                      <a:noFill/>
+                      <a:prstDash val="solid"/>
+                      <a:round/>
+                      <a:headEnd type="none" w="med" len="med"/>
+                      <a:tailEnd type="none" w="med" len="med"/>
+                    </a:lnB>
+                    <a:lnTlToBr w="12700" cmpd="sng">
+                      <a:noFill/>
+                      <a:prstDash val="solid"/>
+                    </a:lnTlToBr>
+                    <a:lnBlToTr w="12700" cmpd="sng">
+                      <a:noFill/>
+                      <a:prstDash val="solid"/>
+                    </a:lnBlToTr>
+                  </a:tcPr>
+                </a:tc>
+                <a:tc>
+                  <a:txBody>
+                    <a:bodyPr/>
+                    <a:lstStyle/>
+                    <a:p>
+                      <a:endParaRPr lang="de-DE" sz="500" dirty="0"/>
+                    </a:p>
+                  </a:txBody>
+                  <a:tcPr>
+                    <a:lnL w="12700" cap="flat" cmpd="sng" algn="ctr">
+                      <a:noFill/>
+                      <a:prstDash val="solid"/>
+                      <a:round/>
+                      <a:headEnd type="none" w="med" len="med"/>
+                      <a:tailEnd type="none" w="med" len="med"/>
+                    </a:lnL>
+                    <a:lnR w="12700" cap="flat" cmpd="sng" algn="ctr">
+                      <a:solidFill>
+                        <a:schemeClr val="tx1"/>
+                      </a:solidFill>
+                      <a:prstDash val="solid"/>
+                      <a:round/>
+                      <a:headEnd type="none" w="med" len="med"/>
+                      <a:tailEnd type="none" w="med" len="med"/>
+                    </a:lnR>
+                    <a:lnT w="12700" cap="flat" cmpd="sng" algn="ctr">
+                      <a:noFill/>
+                      <a:prstDash val="solid"/>
+                      <a:round/>
+                      <a:headEnd type="none" w="med" len="med"/>
+                      <a:tailEnd type="none" w="med" len="med"/>
+                    </a:lnT>
+                    <a:lnB w="12700" cap="flat" cmpd="sng" algn="ctr">
+                      <a:noFill/>
+                      <a:prstDash val="solid"/>
+                      <a:round/>
+                      <a:headEnd type="none" w="med" len="med"/>
+                      <a:tailEnd type="none" w="med" len="med"/>
+                    </a:lnB>
+                    <a:lnTlToBr w="12700" cmpd="sng">
+                      <a:noFill/>
+                      <a:prstDash val="solid"/>
+                    </a:lnTlToBr>
+                    <a:lnBlToTr w="12700" cmpd="sng">
+                      <a:noFill/>
+                      <a:prstDash val="solid"/>
+                    </a:lnBlToTr>
+                  </a:tcPr>
+                </a:tc>
+                <a:tc>
+                  <a:txBody>
+                    <a:bodyPr/>
+                    <a:lstStyle/>
+                    <a:p>
+                      <a:endParaRPr lang="de-DE" sz="500" dirty="0"/>
+                    </a:p>
+                  </a:txBody>
+                  <a:tcPr>
+                    <a:lnL w="12700" cap="flat" cmpd="sng" algn="ctr">
+                      <a:solidFill>
+                        <a:schemeClr val="tx1"/>
+                      </a:solidFill>
+                      <a:prstDash val="solid"/>
+                      <a:round/>
+                      <a:headEnd type="none" w="med" len="med"/>
+                      <a:tailEnd type="none" w="med" len="med"/>
+                    </a:lnL>
+                    <a:lnR w="12700" cap="flat" cmpd="sng" algn="ctr">
+                      <a:noFill/>
+                      <a:prstDash val="solid"/>
+                      <a:round/>
+                      <a:headEnd type="none" w="med" len="med"/>
+                      <a:tailEnd type="none" w="med" len="med"/>
+                    </a:lnR>
+                    <a:lnT w="12700" cap="flat" cmpd="sng" algn="ctr">
+                      <a:noFill/>
+                      <a:prstDash val="solid"/>
+                      <a:round/>
+                      <a:headEnd type="none" w="med" len="med"/>
+                      <a:tailEnd type="none" w="med" len="med"/>
+                    </a:lnT>
+                    <a:lnB w="12700" cap="flat" cmpd="sng" algn="ctr">
+                      <a:noFill/>
+                      <a:prstDash val="solid"/>
+                      <a:round/>
+                      <a:headEnd type="none" w="med" len="med"/>
+                      <a:tailEnd type="none" w="med" len="med"/>
+                    </a:lnB>
+                    <a:lnTlToBr w="12700" cmpd="sng">
+                      <a:noFill/>
+                      <a:prstDash val="solid"/>
+                    </a:lnTlToBr>
+                    <a:lnBlToTr w="12700" cmpd="sng">
+                      <a:noFill/>
+                      <a:prstDash val="solid"/>
+                    </a:lnBlToTr>
+                  </a:tcPr>
+                </a:tc>
+                <a:tc>
+                  <a:txBody>
+                    <a:bodyPr/>
+                    <a:lstStyle/>
+                    <a:p>
+                      <a:endParaRPr lang="de-DE" sz="500" dirty="0"/>
+                    </a:p>
+                  </a:txBody>
+                  <a:tcPr>
+                    <a:lnL w="12700" cap="flat" cmpd="sng" algn="ctr">
+                      <a:noFill/>
+                      <a:prstDash val="solid"/>
+                      <a:round/>
+                      <a:headEnd type="none" w="med" len="med"/>
+                      <a:tailEnd type="none" w="med" len="med"/>
+                    </a:lnL>
+                    <a:lnR w="12700" cap="flat" cmpd="sng" algn="ctr">
+                      <a:solidFill>
+                        <a:schemeClr val="tx1"/>
+                      </a:solidFill>
+                      <a:prstDash val="solid"/>
+                      <a:round/>
+                      <a:headEnd type="none" w="med" len="med"/>
+                      <a:tailEnd type="none" w="med" len="med"/>
+                    </a:lnR>
+                    <a:lnT w="12700" cap="flat" cmpd="sng" algn="ctr">
+                      <a:noFill/>
+                      <a:prstDash val="solid"/>
+                      <a:round/>
+                      <a:headEnd type="none" w="med" len="med"/>
+                      <a:tailEnd type="none" w="med" len="med"/>
+                    </a:lnT>
+                    <a:lnB w="12700" cap="flat" cmpd="sng" algn="ctr">
+                      <a:noFill/>
+                      <a:prstDash val="solid"/>
+                      <a:round/>
+                      <a:headEnd type="none" w="med" len="med"/>
+                      <a:tailEnd type="none" w="med" len="med"/>
+                    </a:lnB>
+                    <a:lnTlToBr w="12700" cmpd="sng">
+                      <a:noFill/>
+                      <a:prstDash val="solid"/>
+                    </a:lnTlToBr>
+                    <a:lnBlToTr w="12700" cmpd="sng">
+                      <a:noFill/>
+                      <a:prstDash val="solid"/>
+                    </a:lnBlToTr>
+                  </a:tcPr>
+                </a:tc>
+                <a:tc>
+                  <a:txBody>
+                    <a:bodyPr/>
+                    <a:lstStyle/>
+                    <a:p>
+                      <a:endParaRPr lang="de-DE" sz="500" dirty="0"/>
+                    </a:p>
+                  </a:txBody>
+                  <a:tcPr>
+                    <a:lnL w="12700" cap="flat" cmpd="sng" algn="ctr">
+                      <a:solidFill>
+                        <a:schemeClr val="tx1"/>
+                      </a:solidFill>
+                      <a:prstDash val="solid"/>
+                      <a:round/>
+                      <a:headEnd type="none" w="med" len="med"/>
+                      <a:tailEnd type="none" w="med" len="med"/>
+                    </a:lnL>
+                    <a:lnR w="12700" cap="flat" cmpd="sng" algn="ctr">
+                      <a:noFill/>
+                      <a:prstDash val="solid"/>
+                      <a:round/>
+                      <a:headEnd type="none" w="med" len="med"/>
+                      <a:tailEnd type="none" w="med" len="med"/>
+                    </a:lnR>
+                    <a:lnT w="12700" cap="flat" cmpd="sng" algn="ctr">
+                      <a:noFill/>
+                      <a:prstDash val="solid"/>
+                      <a:round/>
+                      <a:headEnd type="none" w="med" len="med"/>
+                      <a:tailEnd type="none" w="med" len="med"/>
+                    </a:lnT>
+                    <a:lnB w="12700" cap="flat" cmpd="sng" algn="ctr">
+                      <a:noFill/>
+                      <a:prstDash val="solid"/>
+                      <a:round/>
+                      <a:headEnd type="none" w="med" len="med"/>
+                      <a:tailEnd type="none" w="med" len="med"/>
+                    </a:lnB>
+                    <a:lnTlToBr w="12700" cmpd="sng">
+                      <a:noFill/>
+                      <a:prstDash val="solid"/>
+                    </a:lnTlToBr>
+                    <a:lnBlToTr w="12700" cmpd="sng">
+                      <a:noFill/>
+                      <a:prstDash val="solid"/>
+                    </a:lnBlToTr>
+                  </a:tcPr>
+                </a:tc>
+                <a:tc>
+                  <a:txBody>
+                    <a:bodyPr/>
+                    <a:lstStyle/>
+                    <a:p>
+                      <a:endParaRPr lang="de-DE" sz="500" dirty="0"/>
+                    </a:p>
+                  </a:txBody>
+                  <a:tcPr>
+                    <a:lnL w="12700" cap="flat" cmpd="sng" algn="ctr">
+                      <a:noFill/>
+                      <a:prstDash val="solid"/>
+                      <a:round/>
+                      <a:headEnd type="none" w="med" len="med"/>
+                      <a:tailEnd type="none" w="med" len="med"/>
+                    </a:lnL>
+                    <a:lnR w="12700" cap="flat" cmpd="sng" algn="ctr">
+                      <a:solidFill>
+                        <a:schemeClr val="tx1"/>
+                      </a:solidFill>
+                      <a:prstDash val="solid"/>
+                      <a:round/>
+                      <a:headEnd type="none" w="med" len="med"/>
+                      <a:tailEnd type="none" w="med" len="med"/>
+                    </a:lnR>
+                    <a:lnT w="12700" cap="flat" cmpd="sng" algn="ctr">
+                      <a:noFill/>
+                      <a:prstDash val="solid"/>
+                      <a:round/>
+                      <a:headEnd type="none" w="med" len="med"/>
+                      <a:tailEnd type="none" w="med" len="med"/>
+                    </a:lnT>
+                    <a:lnB w="12700" cap="flat" cmpd="sng" algn="ctr">
+                      <a:noFill/>
+                      <a:prstDash val="solid"/>
+                      <a:round/>
+                      <a:headEnd type="none" w="med" len="med"/>
+                      <a:tailEnd type="none" w="med" len="med"/>
+                    </a:lnB>
+                    <a:lnTlToBr w="12700" cmpd="sng">
+                      <a:noFill/>
+                      <a:prstDash val="solid"/>
+                    </a:lnTlToBr>
+                    <a:lnBlToTr w="12700" cmpd="sng">
+                      <a:noFill/>
+                      <a:prstDash val="solid"/>
+                    </a:lnBlToTr>
+                  </a:tcPr>
+                </a:tc>
+                <a:tc>
+                  <a:txBody>
+                    <a:bodyPr/>
+                    <a:lstStyle/>
+                    <a:p>
+                      <a:endParaRPr lang="de-DE" sz="500" dirty="0"/>
+                    </a:p>
+                  </a:txBody>
+                  <a:tcPr>
+                    <a:lnL w="12700" cap="flat" cmpd="sng" algn="ctr">
+                      <a:solidFill>
+                        <a:schemeClr val="tx1"/>
+                      </a:solidFill>
+                      <a:prstDash val="solid"/>
+                      <a:round/>
+                      <a:headEnd type="none" w="med" len="med"/>
+                      <a:tailEnd type="none" w="med" len="med"/>
+                    </a:lnL>
+                    <a:lnR w="12700" cap="flat" cmpd="sng" algn="ctr">
+                      <a:noFill/>
+                      <a:prstDash val="solid"/>
+                      <a:round/>
+                      <a:headEnd type="none" w="med" len="med"/>
+                      <a:tailEnd type="none" w="med" len="med"/>
+                    </a:lnR>
+                    <a:lnT w="12700" cap="flat" cmpd="sng" algn="ctr">
+                      <a:noFill/>
+                      <a:prstDash val="solid"/>
+                      <a:round/>
+                      <a:headEnd type="none" w="med" len="med"/>
+                      <a:tailEnd type="none" w="med" len="med"/>
+                    </a:lnT>
+                    <a:lnB w="12700" cap="flat" cmpd="sng" algn="ctr">
+                      <a:noFill/>
+                      <a:prstDash val="solid"/>
+                      <a:round/>
+                      <a:headEnd type="none" w="med" len="med"/>
+                      <a:tailEnd type="none" w="med" len="med"/>
+                    </a:lnB>
+                    <a:lnTlToBr w="12700" cmpd="sng">
+                      <a:noFill/>
+                      <a:prstDash val="solid"/>
+                    </a:lnTlToBr>
+                    <a:lnBlToTr w="12700" cmpd="sng">
+                      <a:noFill/>
+                      <a:prstDash val="solid"/>
+                    </a:lnBlToTr>
+                  </a:tcPr>
+                </a:tc>
+                <a:tc>
+                  <a:txBody>
+                    <a:bodyPr/>
+                    <a:lstStyle/>
+                    <a:p>
+                      <a:endParaRPr lang="de-DE" sz="500" dirty="0"/>
+                    </a:p>
+                  </a:txBody>
+                  <a:tcPr>
+                    <a:lnL w="12700" cap="flat" cmpd="sng" algn="ctr">
+                      <a:noFill/>
+                      <a:prstDash val="solid"/>
+                      <a:round/>
+                      <a:headEnd type="none" w="med" len="med"/>
+                      <a:tailEnd type="none" w="med" len="med"/>
+                    </a:lnL>
+                    <a:lnR w="12700" cap="flat" cmpd="sng" algn="ctr">
+                      <a:solidFill>
+                        <a:schemeClr val="tx1"/>
+                      </a:solidFill>
+                      <a:prstDash val="solid"/>
+                      <a:round/>
+                      <a:headEnd type="none" w="med" len="med"/>
+                      <a:tailEnd type="none" w="med" len="med"/>
+                    </a:lnR>
+                    <a:lnT w="12700" cap="flat" cmpd="sng" algn="ctr">
+                      <a:noFill/>
+                      <a:prstDash val="solid"/>
+                      <a:round/>
+                      <a:headEnd type="none" w="med" len="med"/>
+                      <a:tailEnd type="none" w="med" len="med"/>
+                    </a:lnT>
+                    <a:lnB w="12700" cap="flat" cmpd="sng" algn="ctr">
+                      <a:noFill/>
+                      <a:prstDash val="solid"/>
+                      <a:round/>
+                      <a:headEnd type="none" w="med" len="med"/>
+                      <a:tailEnd type="none" w="med" len="med"/>
+                    </a:lnB>
+                    <a:lnTlToBr w="12700" cmpd="sng">
+                      <a:noFill/>
+                      <a:prstDash val="solid"/>
+                    </a:lnTlToBr>
+                    <a:lnBlToTr w="12700" cmpd="sng">
+                      <a:noFill/>
+                      <a:prstDash val="solid"/>
+                    </a:lnBlToTr>
+                  </a:tcPr>
+                </a:tc>
+                <a:tc>
+                  <a:txBody>
+                    <a:bodyPr/>
+                    <a:lstStyle/>
+                    <a:p>
+                      <a:endParaRPr lang="de-DE" sz="500" dirty="0"/>
+                    </a:p>
+                  </a:txBody>
+                  <a:tcPr>
+                    <a:lnL w="12700" cap="flat" cmpd="sng" algn="ctr">
+                      <a:solidFill>
+                        <a:schemeClr val="tx1"/>
+                      </a:solidFill>
+                      <a:prstDash val="solid"/>
+                      <a:round/>
+                      <a:headEnd type="none" w="med" len="med"/>
+                      <a:tailEnd type="none" w="med" len="med"/>
+                    </a:lnL>
+                    <a:lnR w="12700" cap="flat" cmpd="sng" algn="ctr">
+                      <a:noFill/>
+                      <a:prstDash val="solid"/>
+                      <a:round/>
+                      <a:headEnd type="none" w="med" len="med"/>
+                      <a:tailEnd type="none" w="med" len="med"/>
+                    </a:lnR>
+                    <a:lnT w="12700" cap="flat" cmpd="sng" algn="ctr">
+                      <a:noFill/>
+                      <a:prstDash val="solid"/>
+                      <a:round/>
+                      <a:headEnd type="none" w="med" len="med"/>
+                      <a:tailEnd type="none" w="med" len="med"/>
+                    </a:lnT>
+                    <a:lnB w="12700" cap="flat" cmpd="sng" algn="ctr">
+                      <a:noFill/>
+                      <a:prstDash val="solid"/>
+                      <a:round/>
+                      <a:headEnd type="none" w="med" len="med"/>
+                      <a:tailEnd type="none" w="med" len="med"/>
+                    </a:lnB>
+                    <a:lnTlToBr w="12700" cmpd="sng">
+                      <a:noFill/>
+                      <a:prstDash val="solid"/>
+                    </a:lnTlToBr>
+                    <a:lnBlToTr w="12700" cmpd="sng">
+                      <a:noFill/>
+                      <a:prstDash val="solid"/>
+                    </a:lnBlToTr>
+                  </a:tcPr>
+                </a:tc>
+                <a:tc>
+                  <a:txBody>
+                    <a:bodyPr/>
+                    <a:lstStyle/>
+                    <a:p>
+                      <a:endParaRPr lang="de-DE" sz="500" dirty="0"/>
+                    </a:p>
+                  </a:txBody>
+                  <a:tcPr>
+                    <a:lnL w="12700" cap="flat" cmpd="sng" algn="ctr">
+                      <a:noFill/>
+                      <a:prstDash val="solid"/>
+                      <a:round/>
+                      <a:headEnd type="none" w="med" len="med"/>
+                      <a:tailEnd type="none" w="med" len="med"/>
+                    </a:lnL>
+                    <a:lnR w="12700" cap="flat" cmpd="sng" algn="ctr">
+                      <a:solidFill>
+                        <a:schemeClr val="tx1"/>
+                      </a:solidFill>
+                      <a:prstDash val="solid"/>
+                      <a:round/>
+                      <a:headEnd type="none" w="med" len="med"/>
+                      <a:tailEnd type="none" w="med" len="med"/>
+                    </a:lnR>
+                    <a:lnT w="12700" cap="flat" cmpd="sng" algn="ctr">
+                      <a:noFill/>
+                      <a:prstDash val="solid"/>
+                      <a:round/>
+                      <a:headEnd type="none" w="med" len="med"/>
+                      <a:tailEnd type="none" w="med" len="med"/>
+                    </a:lnT>
+                    <a:lnB w="12700" cap="flat" cmpd="sng" algn="ctr">
+                      <a:noFill/>
+                      <a:prstDash val="solid"/>
+                      <a:round/>
+                      <a:headEnd type="none" w="med" len="med"/>
+                      <a:tailEnd type="none" w="med" len="med"/>
+                    </a:lnB>
+                    <a:lnTlToBr w="12700" cmpd="sng">
+                      <a:noFill/>
+                      <a:prstDash val="solid"/>
+                    </a:lnTlToBr>
+                    <a:lnBlToTr w="12700" cmpd="sng">
+                      <a:noFill/>
+                      <a:prstDash val="solid"/>
+                    </a:lnBlToTr>
+                  </a:tcPr>
+                </a:tc>
+                <a:tc>
+                  <a:txBody>
+                    <a:bodyPr/>
+                    <a:lstStyle/>
+                    <a:p>
+                      <a:endParaRPr lang="de-DE" sz="500" dirty="0"/>
+                    </a:p>
+                  </a:txBody>
+                  <a:tcPr>
+                    <a:lnL w="12700" cap="flat" cmpd="sng" algn="ctr">
+                      <a:solidFill>
+                        <a:schemeClr val="tx1"/>
+                      </a:solidFill>
+                      <a:prstDash val="solid"/>
+                      <a:round/>
+                      <a:headEnd type="none" w="med" len="med"/>
+                      <a:tailEnd type="none" w="med" len="med"/>
+                    </a:lnL>
+                    <a:lnR w="12700" cap="flat" cmpd="sng" algn="ctr">
+                      <a:noFill/>
+                      <a:prstDash val="solid"/>
+                      <a:round/>
+                      <a:headEnd type="none" w="med" len="med"/>
+                      <a:tailEnd type="none" w="med" len="med"/>
+                    </a:lnR>
+                    <a:lnT w="12700" cap="flat" cmpd="sng" algn="ctr">
+                      <a:noFill/>
+                      <a:prstDash val="solid"/>
+                      <a:round/>
+                      <a:headEnd type="none" w="med" len="med"/>
+                      <a:tailEnd type="none" w="med" len="med"/>
+                    </a:lnT>
+                    <a:lnB w="12700" cap="flat" cmpd="sng" algn="ctr">
+                      <a:noFill/>
+                      <a:prstDash val="solid"/>
+                      <a:round/>
+                      <a:headEnd type="none" w="med" len="med"/>
+                      <a:tailEnd type="none" w="med" len="med"/>
+                    </a:lnB>
+                    <a:lnTlToBr w="12700" cmpd="sng">
+                      <a:noFill/>
+                      <a:prstDash val="solid"/>
+                    </a:lnTlToBr>
+                    <a:lnBlToTr w="12700" cmpd="sng">
+                      <a:noFill/>
+                      <a:prstDash val="solid"/>
+                    </a:lnBlToTr>
+                  </a:tcPr>
+                </a:tc>
+                <a:extLst>
+                  <a:ext uri="{0D108BD9-81ED-4DB2-BD59-A6C34878D82A}">
+                    <a16:rowId xmlns:a16="http://schemas.microsoft.com/office/drawing/2014/main" val="556338525"/>
+                  </a:ext>
+                </a:extLst>
+              </a:tr>
+              <a:tr h="370840">
+                <a:tc gridSpan="2">
+                  <a:txBody>
+                    <a:bodyPr/>
+                    <a:lstStyle/>
+                    <a:p>
+                      <a:pPr algn="ctr"/>
+                      <a:r>
+                        <a:rPr lang="de-DE" sz="2500" kern="1200" dirty="0">
+                          <a:solidFill>
+                            <a:schemeClr val="tx1"/>
+                          </a:solidFill>
+                          <a:latin typeface="Times New Roman" panose="02020603050405020304" pitchFamily="18" charset="0"/>
+                          <a:ea typeface="+mn-ea"/>
+                          <a:cs typeface="Times New Roman" panose="02020603050405020304" pitchFamily="18" charset="0"/>
+                        </a:rPr>
+                        <a:t>0</a:t>
+                      </a:r>
+                    </a:p>
+                  </a:txBody>
+                  <a:tcPr>
+                    <a:lnL w="12700" cap="flat" cmpd="sng" algn="ctr">
+                      <a:noFill/>
+                      <a:prstDash val="solid"/>
+                      <a:round/>
+                      <a:headEnd type="none" w="med" len="med"/>
+                      <a:tailEnd type="none" w="med" len="med"/>
+                    </a:lnL>
+                    <a:lnR w="12700" cap="flat" cmpd="sng" algn="ctr">
+                      <a:noFill/>
+                      <a:prstDash val="solid"/>
+                      <a:round/>
+                      <a:headEnd type="none" w="med" len="med"/>
+                      <a:tailEnd type="none" w="med" len="med"/>
+                    </a:lnR>
+                    <a:lnT w="12700" cap="flat" cmpd="sng" algn="ctr">
+                      <a:noFill/>
+                      <a:prstDash val="solid"/>
+                      <a:round/>
+                      <a:headEnd type="none" w="med" len="med"/>
+                      <a:tailEnd type="none" w="med" len="med"/>
+                    </a:lnT>
+                    <a:lnB w="12700" cap="flat" cmpd="sng" algn="ctr">
+                      <a:noFill/>
+                      <a:prstDash val="solid"/>
+                      <a:round/>
+                      <a:headEnd type="none" w="med" len="med"/>
+                      <a:tailEnd type="none" w="med" len="med"/>
+                    </a:lnB>
+                    <a:lnTlToBr w="12700" cmpd="sng">
+                      <a:noFill/>
+                      <a:prstDash val="solid"/>
+                    </a:lnTlToBr>
+                    <a:lnBlToTr w="12700" cmpd="sng">
+                      <a:noFill/>
+                      <a:prstDash val="solid"/>
+                    </a:lnBlToTr>
+                  </a:tcPr>
+                </a:tc>
+                <a:tc hMerge="1">
+                  <a:txBody>
+                    <a:bodyPr/>
+                    <a:lstStyle/>
+                    <a:p>
+                      <a:endParaRPr lang="de-DE" dirty="0"/>
+                    </a:p>
+                  </a:txBody>
+                  <a:tcPr>
+                    <a:lnL w="12700" cap="flat" cmpd="sng" algn="ctr">
+                      <a:solidFill>
+                        <a:schemeClr val="tx1"/>
+                      </a:solidFill>
+                      <a:prstDash val="solid"/>
+                      <a:round/>
+                      <a:headEnd type="none" w="med" len="med"/>
+                      <a:tailEnd type="none" w="med" len="med"/>
+                    </a:lnL>
+                    <a:lnR w="12700" cap="flat" cmpd="sng" algn="ctr">
+                      <a:solidFill>
+                        <a:schemeClr val="tx1"/>
+                      </a:solidFill>
+                      <a:prstDash val="solid"/>
+                      <a:round/>
+                      <a:headEnd type="none" w="med" len="med"/>
+                      <a:tailEnd type="none" w="med" len="med"/>
+                    </a:lnR>
+                    <a:lnT w="12700" cap="flat" cmpd="sng" algn="ctr">
+                      <a:solidFill>
+                        <a:schemeClr val="tx1"/>
+                      </a:solidFill>
+                      <a:prstDash val="solid"/>
+                      <a:round/>
+                      <a:headEnd type="none" w="med" len="med"/>
+                      <a:tailEnd type="none" w="med" len="med"/>
+                    </a:lnT>
+                    <a:lnB w="12700" cap="flat" cmpd="sng" algn="ctr">
+                      <a:solidFill>
+                        <a:schemeClr val="tx1"/>
+                      </a:solidFill>
+                      <a:prstDash val="solid"/>
+                      <a:round/>
+                      <a:headEnd type="none" w="med" len="med"/>
+                      <a:tailEnd type="none" w="med" len="med"/>
+                    </a:lnB>
+                    <a:lnTlToBr w="12700" cmpd="sng">
+                      <a:noFill/>
+                      <a:prstDash val="solid"/>
+                    </a:lnTlToBr>
+                    <a:lnBlToTr w="12700" cmpd="sng">
+                      <a:noFill/>
+                      <a:prstDash val="solid"/>
+                    </a:lnBlToTr>
+                  </a:tcPr>
+                </a:tc>
+                <a:tc gridSpan="2">
+                  <a:txBody>
+                    <a:bodyPr/>
+                    <a:lstStyle/>
+                    <a:p>
+                      <a:pPr algn="ctr"/>
+                      <a:r>
+                        <a:rPr lang="de-DE" sz="2500" kern="1200" dirty="0">
+                          <a:solidFill>
+                            <a:schemeClr val="tx1"/>
+                          </a:solidFill>
+                          <a:latin typeface="Times New Roman" panose="02020603050405020304" pitchFamily="18" charset="0"/>
+                          <a:ea typeface="+mn-ea"/>
+                          <a:cs typeface="Times New Roman" panose="02020603050405020304" pitchFamily="18" charset="0"/>
+                        </a:rPr>
+                        <a:t>20</a:t>
+                      </a:r>
+                    </a:p>
+                  </a:txBody>
+                  <a:tcPr>
+                    <a:lnL w="12700" cap="flat" cmpd="sng" algn="ctr">
+                      <a:noFill/>
+                      <a:prstDash val="solid"/>
+                      <a:round/>
+                      <a:headEnd type="none" w="med" len="med"/>
+                      <a:tailEnd type="none" w="med" len="med"/>
+                    </a:lnL>
+                    <a:lnR w="12700" cap="flat" cmpd="sng" algn="ctr">
+                      <a:noFill/>
+                      <a:prstDash val="solid"/>
+                      <a:round/>
+                      <a:headEnd type="none" w="med" len="med"/>
+                      <a:tailEnd type="none" w="med" len="med"/>
+                    </a:lnR>
+                    <a:lnT w="12700" cap="flat" cmpd="sng" algn="ctr">
+                      <a:noFill/>
+                      <a:prstDash val="solid"/>
+                      <a:round/>
+                      <a:headEnd type="none" w="med" len="med"/>
+                      <a:tailEnd type="none" w="med" len="med"/>
+                    </a:lnT>
+                    <a:lnB w="12700" cap="flat" cmpd="sng" algn="ctr">
+                      <a:noFill/>
+                      <a:prstDash val="solid"/>
+                      <a:round/>
+                      <a:headEnd type="none" w="med" len="med"/>
+                      <a:tailEnd type="none" w="med" len="med"/>
+                    </a:lnB>
+                    <a:lnTlToBr w="12700" cmpd="sng">
+                      <a:noFill/>
+                      <a:prstDash val="solid"/>
+                    </a:lnTlToBr>
+                    <a:lnBlToTr w="12700" cmpd="sng">
+                      <a:noFill/>
+                      <a:prstDash val="solid"/>
+                    </a:lnBlToTr>
+                  </a:tcPr>
+                </a:tc>
+                <a:tc hMerge="1">
+                  <a:txBody>
+                    <a:bodyPr/>
+                    <a:lstStyle/>
+                    <a:p>
+                      <a:endParaRPr lang="de-DE" dirty="0"/>
+                    </a:p>
+                  </a:txBody>
+                  <a:tcPr>
+                    <a:lnL w="12700" cap="flat" cmpd="sng" algn="ctr">
+                      <a:solidFill>
+                        <a:schemeClr val="tx1"/>
+                      </a:solidFill>
+                      <a:prstDash val="solid"/>
+                      <a:round/>
+                      <a:headEnd type="none" w="med" len="med"/>
+                      <a:tailEnd type="none" w="med" len="med"/>
+                    </a:lnL>
+                    <a:lnR w="12700" cap="flat" cmpd="sng" algn="ctr">
+                      <a:solidFill>
+                        <a:schemeClr val="tx1"/>
+                      </a:solidFill>
+                      <a:prstDash val="solid"/>
+                      <a:round/>
+                      <a:headEnd type="none" w="med" len="med"/>
+                      <a:tailEnd type="none" w="med" len="med"/>
+                    </a:lnR>
+                    <a:lnT w="12700" cap="flat" cmpd="sng" algn="ctr">
+                      <a:solidFill>
+                        <a:schemeClr val="tx1"/>
+                      </a:solidFill>
+                      <a:prstDash val="solid"/>
+                      <a:round/>
+                      <a:headEnd type="none" w="med" len="med"/>
+                      <a:tailEnd type="none" w="med" len="med"/>
+                    </a:lnT>
+                    <a:lnB w="12700" cap="flat" cmpd="sng" algn="ctr">
+                      <a:solidFill>
+                        <a:schemeClr val="tx1"/>
+                      </a:solidFill>
+                      <a:prstDash val="solid"/>
+                      <a:round/>
+                      <a:headEnd type="none" w="med" len="med"/>
+                      <a:tailEnd type="none" w="med" len="med"/>
+                    </a:lnB>
+                    <a:lnTlToBr w="12700" cmpd="sng">
+                      <a:noFill/>
+                      <a:prstDash val="solid"/>
+                    </a:lnTlToBr>
+                    <a:lnBlToTr w="12700" cmpd="sng">
+                      <a:noFill/>
+                      <a:prstDash val="solid"/>
+                    </a:lnBlToTr>
+                  </a:tcPr>
+                </a:tc>
+                <a:tc gridSpan="2">
+                  <a:txBody>
+                    <a:bodyPr/>
+                    <a:lstStyle/>
+                    <a:p>
+                      <a:pPr algn="ctr"/>
+                      <a:r>
+                        <a:rPr lang="de-DE" sz="2500" kern="1200" dirty="0">
+                          <a:solidFill>
+                            <a:schemeClr val="tx1"/>
+                          </a:solidFill>
+                          <a:latin typeface="Times New Roman" panose="02020603050405020304" pitchFamily="18" charset="0"/>
+                          <a:ea typeface="+mn-ea"/>
+                          <a:cs typeface="Times New Roman" panose="02020603050405020304" pitchFamily="18" charset="0"/>
+                        </a:rPr>
+                        <a:t>40</a:t>
+                      </a:r>
+                    </a:p>
+                  </a:txBody>
+                  <a:tcPr>
+                    <a:lnL w="12700" cap="flat" cmpd="sng" algn="ctr">
+                      <a:noFill/>
+                      <a:prstDash val="solid"/>
+                      <a:round/>
+                      <a:headEnd type="none" w="med" len="med"/>
+                      <a:tailEnd type="none" w="med" len="med"/>
+                    </a:lnL>
+                    <a:lnR w="12700" cap="flat" cmpd="sng" algn="ctr">
+                      <a:noFill/>
+                      <a:prstDash val="solid"/>
+                      <a:round/>
+                      <a:headEnd type="none" w="med" len="med"/>
+                      <a:tailEnd type="none" w="med" len="med"/>
+                    </a:lnR>
+                    <a:lnT w="12700" cap="flat" cmpd="sng" algn="ctr">
+                      <a:noFill/>
+                      <a:prstDash val="solid"/>
+                      <a:round/>
+                      <a:headEnd type="none" w="med" len="med"/>
+                      <a:tailEnd type="none" w="med" len="med"/>
+                    </a:lnT>
+                    <a:lnB w="12700" cap="flat" cmpd="sng" algn="ctr">
+                      <a:noFill/>
+                      <a:prstDash val="solid"/>
+                      <a:round/>
+                      <a:headEnd type="none" w="med" len="med"/>
+                      <a:tailEnd type="none" w="med" len="med"/>
+                    </a:lnB>
+                    <a:lnTlToBr w="12700" cmpd="sng">
+                      <a:noFill/>
+                      <a:prstDash val="solid"/>
+                    </a:lnTlToBr>
+                    <a:lnBlToTr w="12700" cmpd="sng">
+                      <a:noFill/>
+                      <a:prstDash val="solid"/>
+                    </a:lnBlToTr>
+                  </a:tcPr>
+                </a:tc>
+                <a:tc hMerge="1">
+                  <a:txBody>
+                    <a:bodyPr/>
+                    <a:lstStyle/>
+                    <a:p>
+                      <a:endParaRPr lang="de-DE" dirty="0"/>
+                    </a:p>
+                  </a:txBody>
+                  <a:tcPr>
+                    <a:lnL w="12700" cap="flat" cmpd="sng" algn="ctr">
+                      <a:solidFill>
+                        <a:schemeClr val="tx1"/>
+                      </a:solidFill>
+                      <a:prstDash val="solid"/>
+                      <a:round/>
+                      <a:headEnd type="none" w="med" len="med"/>
+                      <a:tailEnd type="none" w="med" len="med"/>
+                    </a:lnL>
+                    <a:lnR w="12700" cap="flat" cmpd="sng" algn="ctr">
+                      <a:solidFill>
+                        <a:schemeClr val="tx1"/>
+                      </a:solidFill>
+                      <a:prstDash val="solid"/>
+                      <a:round/>
+                      <a:headEnd type="none" w="med" len="med"/>
+                      <a:tailEnd type="none" w="med" len="med"/>
+                    </a:lnR>
+                    <a:lnT w="12700" cap="flat" cmpd="sng" algn="ctr">
+                      <a:solidFill>
+                        <a:schemeClr val="tx1"/>
+                      </a:solidFill>
+                      <a:prstDash val="solid"/>
+                      <a:round/>
+                      <a:headEnd type="none" w="med" len="med"/>
+                      <a:tailEnd type="none" w="med" len="med"/>
+                    </a:lnT>
+                    <a:lnB w="12700" cap="flat" cmpd="sng" algn="ctr">
+                      <a:solidFill>
+                        <a:schemeClr val="tx1"/>
+                      </a:solidFill>
+                      <a:prstDash val="solid"/>
+                      <a:round/>
+                      <a:headEnd type="none" w="med" len="med"/>
+                      <a:tailEnd type="none" w="med" len="med"/>
+                    </a:lnB>
+                    <a:lnTlToBr w="12700" cmpd="sng">
+                      <a:noFill/>
+                      <a:prstDash val="solid"/>
+                    </a:lnTlToBr>
+                    <a:lnBlToTr w="12700" cmpd="sng">
+                      <a:noFill/>
+                      <a:prstDash val="solid"/>
+                    </a:lnBlToTr>
+                  </a:tcPr>
+                </a:tc>
+                <a:tc gridSpan="2">
+                  <a:txBody>
+                    <a:bodyPr/>
+                    <a:lstStyle/>
+                    <a:p>
+                      <a:pPr algn="ctr"/>
+                      <a:r>
+                        <a:rPr lang="de-DE" sz="2500" kern="1200" dirty="0">
+                          <a:solidFill>
+                            <a:schemeClr val="tx1"/>
+                          </a:solidFill>
+                          <a:latin typeface="Times New Roman" panose="02020603050405020304" pitchFamily="18" charset="0"/>
+                          <a:ea typeface="+mn-ea"/>
+                          <a:cs typeface="Times New Roman" panose="02020603050405020304" pitchFamily="18" charset="0"/>
+                        </a:rPr>
+                        <a:t>60</a:t>
+                      </a:r>
+                    </a:p>
+                  </a:txBody>
+                  <a:tcPr>
+                    <a:lnL w="12700" cap="flat" cmpd="sng" algn="ctr">
+                      <a:noFill/>
+                      <a:prstDash val="solid"/>
+                      <a:round/>
+                      <a:headEnd type="none" w="med" len="med"/>
+                      <a:tailEnd type="none" w="med" len="med"/>
+                    </a:lnL>
+                    <a:lnR w="12700" cap="flat" cmpd="sng" algn="ctr">
+                      <a:noFill/>
+                      <a:prstDash val="solid"/>
+                      <a:round/>
+                      <a:headEnd type="none" w="med" len="med"/>
+                      <a:tailEnd type="none" w="med" len="med"/>
+                    </a:lnR>
+                    <a:lnT w="12700" cap="flat" cmpd="sng" algn="ctr">
+                      <a:noFill/>
+                      <a:prstDash val="solid"/>
+                      <a:round/>
+                      <a:headEnd type="none" w="med" len="med"/>
+                      <a:tailEnd type="none" w="med" len="med"/>
+                    </a:lnT>
+                    <a:lnB w="12700" cap="flat" cmpd="sng" algn="ctr">
+                      <a:noFill/>
+                      <a:prstDash val="solid"/>
+                      <a:round/>
+                      <a:headEnd type="none" w="med" len="med"/>
+                      <a:tailEnd type="none" w="med" len="med"/>
+                    </a:lnB>
+                    <a:lnTlToBr w="12700" cmpd="sng">
+                      <a:noFill/>
+                      <a:prstDash val="solid"/>
+                    </a:lnTlToBr>
+                    <a:lnBlToTr w="12700" cmpd="sng">
+                      <a:noFill/>
+                      <a:prstDash val="solid"/>
+                    </a:lnBlToTr>
+                  </a:tcPr>
+                </a:tc>
+                <a:tc hMerge="1">
+                  <a:txBody>
+                    <a:bodyPr/>
+                    <a:lstStyle/>
+                    <a:p>
+                      <a:endParaRPr lang="de-DE" dirty="0"/>
+                    </a:p>
+                  </a:txBody>
+                  <a:tcPr>
+                    <a:lnL w="12700" cap="flat" cmpd="sng" algn="ctr">
+                      <a:solidFill>
+                        <a:schemeClr val="tx1"/>
+                      </a:solidFill>
+                      <a:prstDash val="solid"/>
+                      <a:round/>
+                      <a:headEnd type="none" w="med" len="med"/>
+                      <a:tailEnd type="none" w="med" len="med"/>
+                    </a:lnL>
+                    <a:lnR w="12700" cap="flat" cmpd="sng" algn="ctr">
+                      <a:solidFill>
+                        <a:schemeClr val="tx1"/>
+                      </a:solidFill>
+                      <a:prstDash val="solid"/>
+                      <a:round/>
+                      <a:headEnd type="none" w="med" len="med"/>
+                      <a:tailEnd type="none" w="med" len="med"/>
+                    </a:lnR>
+                    <a:lnT w="12700" cap="flat" cmpd="sng" algn="ctr">
+                      <a:solidFill>
+                        <a:schemeClr val="tx1"/>
+                      </a:solidFill>
+                      <a:prstDash val="solid"/>
+                      <a:round/>
+                      <a:headEnd type="none" w="med" len="med"/>
+                      <a:tailEnd type="none" w="med" len="med"/>
+                    </a:lnT>
+                    <a:lnB w="12700" cap="flat" cmpd="sng" algn="ctr">
+                      <a:solidFill>
+                        <a:schemeClr val="tx1"/>
+                      </a:solidFill>
+                      <a:prstDash val="solid"/>
+                      <a:round/>
+                      <a:headEnd type="none" w="med" len="med"/>
+                      <a:tailEnd type="none" w="med" len="med"/>
+                    </a:lnB>
+                    <a:lnTlToBr w="12700" cmpd="sng">
+                      <a:noFill/>
+                      <a:prstDash val="solid"/>
+                    </a:lnTlToBr>
+                    <a:lnBlToTr w="12700" cmpd="sng">
+                      <a:noFill/>
+                      <a:prstDash val="solid"/>
+                    </a:lnBlToTr>
+                  </a:tcPr>
+                </a:tc>
+                <a:tc gridSpan="2">
+                  <a:txBody>
+                    <a:bodyPr/>
+                    <a:lstStyle/>
+                    <a:p>
+                      <a:pPr algn="ctr"/>
+                      <a:r>
+                        <a:rPr lang="de-DE" sz="2500" kern="1200" dirty="0">
+                          <a:solidFill>
+                            <a:schemeClr val="tx1"/>
+                          </a:solidFill>
+                          <a:latin typeface="Times New Roman" panose="02020603050405020304" pitchFamily="18" charset="0"/>
+                          <a:ea typeface="+mn-ea"/>
+                          <a:cs typeface="Times New Roman" panose="02020603050405020304" pitchFamily="18" charset="0"/>
+                        </a:rPr>
+                        <a:t>80</a:t>
+                      </a:r>
+                    </a:p>
+                  </a:txBody>
+                  <a:tcPr>
+                    <a:lnL w="12700" cap="flat" cmpd="sng" algn="ctr">
+                      <a:noFill/>
+                      <a:prstDash val="solid"/>
+                      <a:round/>
+                      <a:headEnd type="none" w="med" len="med"/>
+                      <a:tailEnd type="none" w="med" len="med"/>
+                    </a:lnL>
+                    <a:lnR w="12700" cap="flat" cmpd="sng" algn="ctr">
+                      <a:noFill/>
+                      <a:prstDash val="solid"/>
+                      <a:round/>
+                      <a:headEnd type="none" w="med" len="med"/>
+                      <a:tailEnd type="none" w="med" len="med"/>
+                    </a:lnR>
+                    <a:lnT w="12700" cap="flat" cmpd="sng" algn="ctr">
+                      <a:noFill/>
+                      <a:prstDash val="solid"/>
+                      <a:round/>
+                      <a:headEnd type="none" w="med" len="med"/>
+                      <a:tailEnd type="none" w="med" len="med"/>
+                    </a:lnT>
+                    <a:lnB w="12700" cap="flat" cmpd="sng" algn="ctr">
+                      <a:noFill/>
+                      <a:prstDash val="solid"/>
+                      <a:round/>
+                      <a:headEnd type="none" w="med" len="med"/>
+                      <a:tailEnd type="none" w="med" len="med"/>
+                    </a:lnB>
+                    <a:lnTlToBr w="12700" cmpd="sng">
+                      <a:noFill/>
+                      <a:prstDash val="solid"/>
+                    </a:lnTlToBr>
+                    <a:lnBlToTr w="12700" cmpd="sng">
+                      <a:noFill/>
+                      <a:prstDash val="solid"/>
+                    </a:lnBlToTr>
+                  </a:tcPr>
+                </a:tc>
+                <a:tc hMerge="1">
+                  <a:txBody>
+                    <a:bodyPr/>
+                    <a:lstStyle/>
+                    <a:p>
+                      <a:endParaRPr lang="de-DE" dirty="0"/>
+                    </a:p>
+                  </a:txBody>
+                  <a:tcPr>
+                    <a:lnL w="12700" cap="flat" cmpd="sng" algn="ctr">
+                      <a:solidFill>
+                        <a:schemeClr val="tx1"/>
+                      </a:solidFill>
+                      <a:prstDash val="solid"/>
+                      <a:round/>
+                      <a:headEnd type="none" w="med" len="med"/>
+                      <a:tailEnd type="none" w="med" len="med"/>
+                    </a:lnL>
+                    <a:lnR w="12700" cap="flat" cmpd="sng" algn="ctr">
+                      <a:solidFill>
+                        <a:schemeClr val="tx1"/>
+                      </a:solidFill>
+                      <a:prstDash val="solid"/>
+                      <a:round/>
+                      <a:headEnd type="none" w="med" len="med"/>
+                      <a:tailEnd type="none" w="med" len="med"/>
+                    </a:lnR>
+                    <a:lnT w="12700" cap="flat" cmpd="sng" algn="ctr">
+                      <a:solidFill>
+                        <a:schemeClr val="tx1"/>
+                      </a:solidFill>
+                      <a:prstDash val="solid"/>
+                      <a:round/>
+                      <a:headEnd type="none" w="med" len="med"/>
+                      <a:tailEnd type="none" w="med" len="med"/>
+                    </a:lnT>
+                    <a:lnB w="12700" cap="flat" cmpd="sng" algn="ctr">
+                      <a:solidFill>
+                        <a:schemeClr val="tx1"/>
+                      </a:solidFill>
+                      <a:prstDash val="solid"/>
+                      <a:round/>
+                      <a:headEnd type="none" w="med" len="med"/>
+                      <a:tailEnd type="none" w="med" len="med"/>
+                    </a:lnB>
+                    <a:lnTlToBr w="12700" cmpd="sng">
+                      <a:noFill/>
+                      <a:prstDash val="solid"/>
+                    </a:lnTlToBr>
+                    <a:lnBlToTr w="12700" cmpd="sng">
+                      <a:noFill/>
+                      <a:prstDash val="solid"/>
+                    </a:lnBlToTr>
+                  </a:tcPr>
+                </a:tc>
+                <a:tc gridSpan="2">
+                  <a:txBody>
+                    <a:bodyPr/>
+                    <a:lstStyle/>
+                    <a:p>
+                      <a:pPr algn="ctr"/>
+                      <a:r>
+                        <a:rPr lang="de-DE" sz="2500" kern="1200" dirty="0">
+                          <a:solidFill>
+                            <a:schemeClr val="tx1"/>
+                          </a:solidFill>
+                          <a:latin typeface="Times New Roman" panose="02020603050405020304" pitchFamily="18" charset="0"/>
+                          <a:ea typeface="+mn-ea"/>
+                          <a:cs typeface="Times New Roman" panose="02020603050405020304" pitchFamily="18" charset="0"/>
+                        </a:rPr>
+                        <a:t>100</a:t>
+                      </a:r>
+                    </a:p>
+                  </a:txBody>
+                  <a:tcPr>
+                    <a:lnL w="12700" cap="flat" cmpd="sng" algn="ctr">
+                      <a:noFill/>
+                      <a:prstDash val="solid"/>
+                      <a:round/>
+                      <a:headEnd type="none" w="med" len="med"/>
+                      <a:tailEnd type="none" w="med" len="med"/>
+                    </a:lnL>
+                    <a:lnR w="12700" cap="flat" cmpd="sng" algn="ctr">
+                      <a:noFill/>
+                      <a:prstDash val="solid"/>
+                      <a:round/>
+                      <a:headEnd type="none" w="med" len="med"/>
+                      <a:tailEnd type="none" w="med" len="med"/>
+                    </a:lnR>
+                    <a:lnT w="12700" cap="flat" cmpd="sng" algn="ctr">
+                      <a:noFill/>
+                      <a:prstDash val="solid"/>
+                      <a:round/>
+                      <a:headEnd type="none" w="med" len="med"/>
+                      <a:tailEnd type="none" w="med" len="med"/>
+                    </a:lnT>
+                    <a:lnB w="12700" cap="flat" cmpd="sng" algn="ctr">
+                      <a:noFill/>
+                      <a:prstDash val="solid"/>
+                      <a:round/>
+                      <a:headEnd type="none" w="med" len="med"/>
+                      <a:tailEnd type="none" w="med" len="med"/>
+                    </a:lnB>
+                    <a:lnTlToBr w="12700" cmpd="sng">
+                      <a:noFill/>
+                      <a:prstDash val="solid"/>
+                    </a:lnTlToBr>
+                    <a:lnBlToTr w="12700" cmpd="sng">
+                      <a:noFill/>
+                      <a:prstDash val="solid"/>
+                    </a:lnBlToTr>
+                  </a:tcPr>
+                </a:tc>
+                <a:tc hMerge="1">
+                  <a:txBody>
+                    <a:bodyPr/>
+                    <a:lstStyle/>
+                    <a:p>
+                      <a:endParaRPr lang="de-DE" dirty="0"/>
+                    </a:p>
+                  </a:txBody>
+                  <a:tcPr>
+                    <a:lnL w="12700" cap="flat" cmpd="sng" algn="ctr">
+                      <a:solidFill>
+                        <a:schemeClr val="tx1"/>
+                      </a:solidFill>
+                      <a:prstDash val="solid"/>
+                      <a:round/>
+                      <a:headEnd type="none" w="med" len="med"/>
+                      <a:tailEnd type="none" w="med" len="med"/>
+                    </a:lnL>
+                    <a:lnR w="12700" cap="flat" cmpd="sng" algn="ctr">
+                      <a:solidFill>
+                        <a:schemeClr val="tx1"/>
+                      </a:solidFill>
+                      <a:prstDash val="solid"/>
+                      <a:round/>
+                      <a:headEnd type="none" w="med" len="med"/>
+                      <a:tailEnd type="none" w="med" len="med"/>
+                    </a:lnR>
+                    <a:lnT w="12700" cap="flat" cmpd="sng" algn="ctr">
+                      <a:solidFill>
+                        <a:schemeClr val="tx1"/>
+                      </a:solidFill>
+                      <a:prstDash val="solid"/>
+                      <a:round/>
+                      <a:headEnd type="none" w="med" len="med"/>
+                      <a:tailEnd type="none" w="med" len="med"/>
+                    </a:lnT>
+                    <a:lnB w="12700" cap="flat" cmpd="sng" algn="ctr">
+                      <a:solidFill>
+                        <a:schemeClr val="tx1"/>
+                      </a:solidFill>
+                      <a:prstDash val="solid"/>
+                      <a:round/>
+                      <a:headEnd type="none" w="med" len="med"/>
+                      <a:tailEnd type="none" w="med" len="med"/>
+                    </a:lnB>
+                    <a:lnTlToBr w="12700" cmpd="sng">
+                      <a:noFill/>
+                      <a:prstDash val="solid"/>
+                    </a:lnTlToBr>
+                    <a:lnBlToTr w="12700" cmpd="sng">
+                      <a:noFill/>
+                      <a:prstDash val="solid"/>
+                    </a:lnBlToTr>
+                  </a:tcPr>
+                </a:tc>
+                <a:extLst>
+                  <a:ext uri="{0D108BD9-81ED-4DB2-BD59-A6C34878D82A}">
+                    <a16:rowId xmlns:a16="http://schemas.microsoft.com/office/drawing/2014/main" val="3568978587"/>
+                  </a:ext>
+                </a:extLst>
+              </a:tr>
+            </a:tbl>
+          </a:graphicData>
+        </a:graphic>
+      </p:graphicFrame>
+      <p:sp>
+        <p:nvSpPr>
+          <p:cNvPr id="22" name="Rechteck 21">
+            <a:extLst>
+              <a:ext uri="{FF2B5EF4-FFF2-40B4-BE49-F238E27FC236}">
+                <a16:creationId xmlns:a16="http://schemas.microsoft.com/office/drawing/2014/main" id="{297FB0F3-01E6-A149-5C15-2E91A16D2A9F}"/>
+              </a:ext>
+            </a:extLst>
+          </p:cNvPr>
+          <p:cNvSpPr/>
+          <p:nvPr/>
+        </p:nvSpPr>
+        <p:spPr>
+          <a:xfrm>
+            <a:off x="111270" y="5544466"/>
+            <a:ext cx="9360746" cy="350972"/>
+          </a:xfrm>
+          <a:prstGeom prst="rect">
+            <a:avLst/>
+          </a:prstGeom>
+          <a:gradFill>
+            <a:gsLst>
+              <a:gs pos="50000">
+                <a:srgbClr val="FFF201"/>
+              </a:gs>
+              <a:gs pos="85000">
+                <a:srgbClr val="FF4593"/>
+              </a:gs>
+              <a:gs pos="70000">
+                <a:srgbClr val="FF9433"/>
+              </a:gs>
+              <a:gs pos="60000">
+                <a:srgbClr val="FFC210"/>
+              </a:gs>
+              <a:gs pos="40000">
+                <a:srgbClr val="D9FF06"/>
+              </a:gs>
+              <a:gs pos="20000">
+                <a:srgbClr val="7BFF4C"/>
+              </a:gs>
+              <a:gs pos="10000">
+                <a:srgbClr val="45FF93"/>
+              </a:gs>
+              <a:gs pos="30000">
+                <a:srgbClr val="ABFF1F"/>
+              </a:gs>
+              <a:gs pos="0">
+                <a:srgbClr val="00FFFF"/>
+              </a:gs>
+              <a:gs pos="95000">
+                <a:srgbClr val="FF00FF"/>
+              </a:gs>
+            </a:gsLst>
+            <a:lin ang="0" scaled="0"/>
+          </a:gradFill>
+          <a:ln>
+            <a:noFill/>
+          </a:ln>
+        </p:spPr>
+        <p:style>
+          <a:lnRef idx="2">
+            <a:schemeClr val="accent1">
+              <a:shade val="15000"/>
+            </a:schemeClr>
+          </a:lnRef>
+          <a:fillRef idx="1">
+            <a:schemeClr val="accent1"/>
+          </a:fillRef>
+          <a:effectRef idx="0">
+            <a:schemeClr val="accent1"/>
+          </a:effectRef>
+          <a:fontRef idx="minor">
+            <a:schemeClr val="lt1"/>
+          </a:fontRef>
+        </p:style>
+        <p:txBody>
+          <a:bodyPr rtlCol="0" anchor="ctr"/>
+          <a:lstStyle/>
+          <a:p>
+            <a:pPr algn="ctr"/>
+            <a:endParaRPr lang="de-DE"/>
+          </a:p>
+        </p:txBody>
+      </p:sp>
+      <p:sp>
+        <p:nvSpPr>
+          <p:cNvPr id="30" name="Textfeld 29">
+            <a:extLst>
+              <a:ext uri="{FF2B5EF4-FFF2-40B4-BE49-F238E27FC236}">
+                <a16:creationId xmlns:a16="http://schemas.microsoft.com/office/drawing/2014/main" id="{52BF42C4-2EED-B4B3-30B6-3F53A5BCEDC4}"/>
+              </a:ext>
+            </a:extLst>
+          </p:cNvPr>
+          <p:cNvSpPr txBox="1"/>
+          <p:nvPr/>
+        </p:nvSpPr>
+        <p:spPr>
+          <a:xfrm>
+            <a:off x="9840642" y="6036712"/>
+            <a:ext cx="1091514" cy="477054"/>
+          </a:xfrm>
+          <a:prstGeom prst="rect">
+            <a:avLst/>
+          </a:prstGeom>
+          <a:noFill/>
+        </p:spPr>
+        <p:txBody>
+          <a:bodyPr wrap="square">
+            <a:spAutoFit/>
+          </a:bodyPr>
+          <a:lstStyle/>
+          <a:p>
+            <a:pPr algn="ctr"/>
+            <a:r>
+              <a:rPr lang="de-DE" sz="2500" kern="1200" dirty="0">
+                <a:solidFill>
+                  <a:schemeClr val="tx1"/>
+                </a:solidFill>
+                <a:latin typeface="Times New Roman" panose="02020603050405020304" pitchFamily="18" charset="0"/>
+                <a:ea typeface="+mn-ea"/>
+                <a:cs typeface="Times New Roman" panose="02020603050405020304" pitchFamily="18" charset="0"/>
+              </a:rPr>
+              <a:t>B[</a:t>
+            </a:r>
+            <a:r>
+              <a:rPr lang="de-DE" sz="2500" kern="1200" dirty="0" err="1">
+                <a:solidFill>
+                  <a:schemeClr val="tx1"/>
+                </a:solidFill>
+                <a:latin typeface="Times New Roman" panose="02020603050405020304" pitchFamily="18" charset="0"/>
+                <a:ea typeface="+mn-ea"/>
+                <a:cs typeface="Times New Roman" panose="02020603050405020304" pitchFamily="18" charset="0"/>
+              </a:rPr>
+              <a:t>mT</a:t>
+            </a:r>
+            <a:r>
+              <a:rPr lang="de-DE" sz="2500" kern="1200" dirty="0">
+                <a:solidFill>
+                  <a:schemeClr val="tx1"/>
+                </a:solidFill>
+                <a:latin typeface="Times New Roman" panose="02020603050405020304" pitchFamily="18" charset="0"/>
+                <a:ea typeface="+mn-ea"/>
+                <a:cs typeface="Times New Roman" panose="02020603050405020304" pitchFamily="18" charset="0"/>
+              </a:rPr>
+              <a:t>]</a:t>
+            </a:r>
+          </a:p>
+        </p:txBody>
+      </p:sp>
+      <p:sp>
+        <p:nvSpPr>
+          <p:cNvPr id="9" name="Rechteck 8">
+            <a:extLst>
+              <a:ext uri="{FF2B5EF4-FFF2-40B4-BE49-F238E27FC236}">
+                <a16:creationId xmlns:a16="http://schemas.microsoft.com/office/drawing/2014/main" id="{EC316A26-0523-0945-9A40-972BDF689013}"/>
+              </a:ext>
+            </a:extLst>
+          </p:cNvPr>
+          <p:cNvSpPr/>
+          <p:nvPr/>
+        </p:nvSpPr>
+        <p:spPr>
+          <a:xfrm>
+            <a:off x="9472016" y="5544466"/>
+            <a:ext cx="1316582" cy="350972"/>
+          </a:xfrm>
+          <a:prstGeom prst="rect">
+            <a:avLst/>
+          </a:prstGeom>
+          <a:solidFill>
+            <a:srgbClr val="FF00FF"/>
+          </a:solidFill>
+          <a:ln>
+            <a:noFill/>
+          </a:ln>
+        </p:spPr>
+        <p:style>
+          <a:lnRef idx="2">
+            <a:schemeClr val="accent1">
+              <a:shade val="15000"/>
+            </a:schemeClr>
+          </a:lnRef>
+          <a:fillRef idx="1">
+            <a:schemeClr val="accent1"/>
+          </a:fillRef>
+          <a:effectRef idx="0">
+            <a:schemeClr val="accent1"/>
+          </a:effectRef>
+          <a:fontRef idx="minor">
+            <a:schemeClr val="lt1"/>
+          </a:fontRef>
+        </p:style>
+        <p:txBody>
+          <a:bodyPr rtlCol="0" anchor="ctr"/>
+          <a:lstStyle/>
+          <a:p>
+            <a:pPr algn="ctr"/>
+            <a:endParaRPr lang="de-DE"/>
+          </a:p>
+        </p:txBody>
+      </p:sp>
+      <p:grpSp>
+        <p:nvGrpSpPr>
+          <p:cNvPr id="18" name="Gruppieren 17">
+            <a:extLst>
+              <a:ext uri="{FF2B5EF4-FFF2-40B4-BE49-F238E27FC236}">
+                <a16:creationId xmlns:a16="http://schemas.microsoft.com/office/drawing/2014/main" id="{66307E74-EBD5-CE09-1B15-2421D8C8E985}"/>
+              </a:ext>
+            </a:extLst>
+          </p:cNvPr>
+          <p:cNvGrpSpPr/>
+          <p:nvPr/>
+        </p:nvGrpSpPr>
+        <p:grpSpPr>
+          <a:xfrm flipH="1">
+            <a:off x="9547312" y="5330165"/>
+            <a:ext cx="468902" cy="782838"/>
+            <a:chOff x="9547312" y="5330165"/>
+            <a:chExt cx="468902" cy="782838"/>
+          </a:xfrm>
+        </p:grpSpPr>
+        <p:sp>
+          <p:nvSpPr>
+            <p:cNvPr id="10" name="Parallelogramm 9">
+              <a:extLst>
+                <a:ext uri="{FF2B5EF4-FFF2-40B4-BE49-F238E27FC236}">
+                  <a16:creationId xmlns:a16="http://schemas.microsoft.com/office/drawing/2014/main" id="{D570A90B-68B3-FE10-4CE8-31DF40441FBF}"/>
+                </a:ext>
+              </a:extLst>
+            </p:cNvPr>
+            <p:cNvSpPr/>
+            <p:nvPr/>
+          </p:nvSpPr>
+          <p:spPr>
+            <a:xfrm flipH="1">
+              <a:off x="9639903" y="5408273"/>
+              <a:ext cx="277245" cy="623303"/>
+            </a:xfrm>
+            <a:prstGeom prst="parallelogram">
+              <a:avLst>
+                <a:gd name="adj" fmla="val 59975"/>
+              </a:avLst>
+            </a:prstGeom>
+            <a:solidFill>
+              <a:schemeClr val="bg1"/>
+            </a:solidFill>
+            <a:ln w="12700">
+              <a:solidFill>
+                <a:schemeClr val="tx1"/>
+              </a:solidFill>
+            </a:ln>
+          </p:spPr>
+          <p:style>
+            <a:lnRef idx="2">
+              <a:schemeClr val="accent1">
+                <a:shade val="15000"/>
+              </a:schemeClr>
+            </a:lnRef>
+            <a:fillRef idx="1">
+              <a:schemeClr val="accent1"/>
+            </a:fillRef>
+            <a:effectRef idx="0">
+              <a:schemeClr val="accent1"/>
+            </a:effectRef>
+            <a:fontRef idx="minor">
+              <a:schemeClr val="lt1"/>
+            </a:fontRef>
+          </p:style>
+          <p:txBody>
+            <a:bodyPr rtlCol="0" anchor="ctr"/>
+            <a:lstStyle/>
+            <a:p>
+              <a:pPr algn="ctr"/>
+              <a:endParaRPr lang="de-DE"/>
+            </a:p>
+          </p:txBody>
+        </p:sp>
+        <p:sp>
+          <p:nvSpPr>
+            <p:cNvPr id="11" name="Rechteck 10">
+              <a:extLst>
+                <a:ext uri="{FF2B5EF4-FFF2-40B4-BE49-F238E27FC236}">
+                  <a16:creationId xmlns:a16="http://schemas.microsoft.com/office/drawing/2014/main" id="{753B4D4F-E6FB-367A-E487-8C43F7DC0C04}"/>
+                </a:ext>
+              </a:extLst>
+            </p:cNvPr>
+            <p:cNvSpPr/>
+            <p:nvPr/>
+          </p:nvSpPr>
+          <p:spPr>
+            <a:xfrm>
+              <a:off x="9547312" y="5330165"/>
+              <a:ext cx="277246" cy="104775"/>
+            </a:xfrm>
+            <a:prstGeom prst="rect">
+              <a:avLst/>
+            </a:prstGeom>
+            <a:solidFill>
+              <a:schemeClr val="bg1"/>
+            </a:solidFill>
+            <a:ln>
+              <a:solidFill>
+                <a:schemeClr val="bg1"/>
+              </a:solidFill>
+            </a:ln>
+          </p:spPr>
+          <p:style>
+            <a:lnRef idx="2">
+              <a:schemeClr val="accent1">
+                <a:shade val="15000"/>
+              </a:schemeClr>
+            </a:lnRef>
+            <a:fillRef idx="1">
+              <a:schemeClr val="accent1"/>
+            </a:fillRef>
+            <a:effectRef idx="0">
+              <a:schemeClr val="accent1"/>
+            </a:effectRef>
+            <a:fontRef idx="minor">
+              <a:schemeClr val="lt1"/>
+            </a:fontRef>
+          </p:style>
+          <p:txBody>
+            <a:bodyPr rtlCol="0" anchor="ctr"/>
+            <a:lstStyle/>
+            <a:p>
+              <a:pPr algn="ctr"/>
+              <a:endParaRPr lang="de-DE"/>
+            </a:p>
+          </p:txBody>
+        </p:sp>
+        <p:sp>
+          <p:nvSpPr>
+            <p:cNvPr id="12" name="Rechteck 11">
+              <a:extLst>
+                <a:ext uri="{FF2B5EF4-FFF2-40B4-BE49-F238E27FC236}">
+                  <a16:creationId xmlns:a16="http://schemas.microsoft.com/office/drawing/2014/main" id="{3C5F8F8C-32CD-27B6-FAA5-B585B0CF3446}"/>
+                </a:ext>
+              </a:extLst>
+            </p:cNvPr>
+            <p:cNvSpPr/>
+            <p:nvPr/>
+          </p:nvSpPr>
+          <p:spPr>
+            <a:xfrm>
+              <a:off x="9738968" y="6008228"/>
+              <a:ext cx="277246" cy="104775"/>
+            </a:xfrm>
+            <a:prstGeom prst="rect">
+              <a:avLst/>
+            </a:prstGeom>
+            <a:solidFill>
+              <a:schemeClr val="bg1"/>
+            </a:solidFill>
+            <a:ln>
+              <a:solidFill>
+                <a:schemeClr val="bg1"/>
+              </a:solidFill>
+            </a:ln>
+          </p:spPr>
+          <p:style>
+            <a:lnRef idx="2">
+              <a:schemeClr val="accent1">
+                <a:shade val="15000"/>
+              </a:schemeClr>
+            </a:lnRef>
+            <a:fillRef idx="1">
+              <a:schemeClr val="accent1"/>
+            </a:fillRef>
+            <a:effectRef idx="0">
+              <a:schemeClr val="accent1"/>
+            </a:effectRef>
+            <a:fontRef idx="minor">
+              <a:schemeClr val="lt1"/>
+            </a:fontRef>
+          </p:style>
+          <p:txBody>
+            <a:bodyPr rtlCol="0" anchor="ctr"/>
+            <a:lstStyle/>
+            <a:p>
+              <a:pPr algn="ctr"/>
+              <a:endParaRPr lang="de-DE"/>
+            </a:p>
+          </p:txBody>
+        </p:sp>
+      </p:grpSp>
+      <p:pic>
+        <p:nvPicPr>
+          <p:cNvPr id="2" name="Inhaltsplatzhalter 5" descr="Ein Bild, das Text, Diagramm, Screenshot, Farbigkeit enthält.&#10;&#10;KI-generierte Inhalte können fehlerhaft sein.">
+            <a:extLst>
+              <a:ext uri="{FF2B5EF4-FFF2-40B4-BE49-F238E27FC236}">
+                <a16:creationId xmlns:a16="http://schemas.microsoft.com/office/drawing/2014/main" id="{3717E753-051A-37EE-A58C-3CDC4BC133C0}"/>
+              </a:ext>
+            </a:extLst>
+          </p:cNvPr>
+          <p:cNvPicPr>
+            <a:picLocks noChangeAspect="1"/>
+          </p:cNvPicPr>
+          <p:nvPr/>
+        </p:nvPicPr>
+        <p:blipFill>
+          <a:blip r:embed="rId2">
+            <a:extLst>
+              <a:ext uri="{28A0092B-C50C-407E-A947-70E740481C1C}">
+                <a14:useLocalDpi xmlns:a14="http://schemas.microsoft.com/office/drawing/2010/main" val="0"/>
+              </a:ext>
+            </a:extLst>
+          </a:blip>
+          <a:srcRect l="1920" t="44503" r="27931" b="932"/>
+          <a:stretch/>
+        </p:blipFill>
+        <p:spPr>
+          <a:xfrm>
+            <a:off x="120497" y="147374"/>
+            <a:ext cx="5250721" cy="2046987"/>
+          </a:xfrm>
+          <a:prstGeom prst="rect">
+            <a:avLst/>
+          </a:prstGeom>
+          <a:ln w="9525">
+            <a:noFill/>
+            <a:miter lim="800000"/>
+            <a:headEnd/>
+            <a:tailEnd/>
+          </a:ln>
+        </p:spPr>
+      </p:pic>
+      <p:sp>
+        <p:nvSpPr>
+          <p:cNvPr id="3" name="Textfeld 2">
+            <a:extLst>
+              <a:ext uri="{FF2B5EF4-FFF2-40B4-BE49-F238E27FC236}">
+                <a16:creationId xmlns:a16="http://schemas.microsoft.com/office/drawing/2014/main" id="{AFC07EB9-36AC-AAB6-A4EE-0F1BD9E6423E}"/>
+              </a:ext>
+            </a:extLst>
+          </p:cNvPr>
+          <p:cNvSpPr txBox="1"/>
+          <p:nvPr/>
+        </p:nvSpPr>
+        <p:spPr>
+          <a:xfrm>
+            <a:off x="111270" y="2194361"/>
+            <a:ext cx="5259948" cy="477054"/>
+          </a:xfrm>
+          <a:prstGeom prst="rect">
+            <a:avLst/>
+          </a:prstGeom>
+          <a:noFill/>
+        </p:spPr>
+        <p:txBody>
+          <a:bodyPr wrap="square" rtlCol="0">
+            <a:spAutoFit/>
+          </a:bodyPr>
+          <a:lstStyle/>
+          <a:p>
+            <a:pPr algn="ctr"/>
+            <a:r>
+              <a:rPr lang="de-DE" sz="2500" dirty="0">
+                <a:latin typeface="Times New Roman" panose="02020603050405020304" pitchFamily="18" charset="0"/>
+                <a:cs typeface="Times New Roman" panose="02020603050405020304" pitchFamily="18" charset="0"/>
+              </a:rPr>
+              <a:t>(a) Neg. Coupling DC</a:t>
+            </a:r>
+          </a:p>
+        </p:txBody>
+      </p:sp>
+      <p:pic>
+        <p:nvPicPr>
+          <p:cNvPr id="16" name="Grafik 15" descr="Ein Bild, das Farbigkeit, Screenshot, Diagramm, Design enthält.&#10;&#10;KI-generierte Inhalte können fehlerhaft sein.">
+            <a:extLst>
+              <a:ext uri="{FF2B5EF4-FFF2-40B4-BE49-F238E27FC236}">
+                <a16:creationId xmlns:a16="http://schemas.microsoft.com/office/drawing/2014/main" id="{F2480594-D856-6F60-E408-A552B7E02412}"/>
+              </a:ext>
+            </a:extLst>
+          </p:cNvPr>
+          <p:cNvPicPr>
+            <a:picLocks noChangeAspect="1"/>
+          </p:cNvPicPr>
+          <p:nvPr/>
+        </p:nvPicPr>
+        <p:blipFill>
+          <a:blip r:embed="rId3">
+            <a:extLst>
+              <a:ext uri="{28A0092B-C50C-407E-A947-70E740481C1C}">
+                <a14:useLocalDpi xmlns:a14="http://schemas.microsoft.com/office/drawing/2010/main" val="0"/>
+              </a:ext>
+            </a:extLst>
+          </a:blip>
+          <a:srcRect l="2232" t="45065" r="28379" b="1423"/>
+          <a:stretch/>
+        </p:blipFill>
+        <p:spPr>
+          <a:xfrm>
+            <a:off x="120497" y="2809936"/>
+            <a:ext cx="5250721" cy="2031839"/>
+          </a:xfrm>
+          <a:prstGeom prst="rect">
+            <a:avLst/>
+          </a:prstGeom>
+        </p:spPr>
+      </p:pic>
+      <p:sp>
+        <p:nvSpPr>
+          <p:cNvPr id="20" name="Textfeld 19">
+            <a:extLst>
+              <a:ext uri="{FF2B5EF4-FFF2-40B4-BE49-F238E27FC236}">
+                <a16:creationId xmlns:a16="http://schemas.microsoft.com/office/drawing/2014/main" id="{9407F2B4-98D8-3E4A-2AAB-1559618AEB7D}"/>
+              </a:ext>
+            </a:extLst>
+          </p:cNvPr>
+          <p:cNvSpPr txBox="1"/>
+          <p:nvPr/>
+        </p:nvSpPr>
+        <p:spPr>
+          <a:xfrm>
+            <a:off x="120497" y="4840213"/>
+            <a:ext cx="5250721" cy="477054"/>
+          </a:xfrm>
+          <a:prstGeom prst="rect">
+            <a:avLst/>
+          </a:prstGeom>
+          <a:noFill/>
+        </p:spPr>
+        <p:txBody>
+          <a:bodyPr wrap="square" rtlCol="0">
+            <a:spAutoFit/>
+          </a:bodyPr>
+          <a:lstStyle/>
+          <a:p>
+            <a:pPr algn="ctr"/>
+            <a:r>
+              <a:rPr lang="de-DE" sz="2500" dirty="0">
+                <a:latin typeface="Times New Roman" panose="02020603050405020304" pitchFamily="18" charset="0"/>
+                <a:cs typeface="Times New Roman" panose="02020603050405020304" pitchFamily="18" charset="0"/>
+              </a:rPr>
+              <a:t>(c) Neg. Coupling Fundamental</a:t>
+            </a:r>
+          </a:p>
+        </p:txBody>
+      </p:sp>
+      <p:pic>
+        <p:nvPicPr>
+          <p:cNvPr id="21" name="Grafik 20" descr="Ein Bild, das Text, Screenshot, Diagramm, Farbigkeit enthält.&#10;&#10;KI-generierte Inhalte können fehlerhaft sein.">
+            <a:extLst>
+              <a:ext uri="{FF2B5EF4-FFF2-40B4-BE49-F238E27FC236}">
+                <a16:creationId xmlns:a16="http://schemas.microsoft.com/office/drawing/2014/main" id="{F7645A6E-DF69-033C-484B-C859D50A6990}"/>
+              </a:ext>
+            </a:extLst>
+          </p:cNvPr>
+          <p:cNvPicPr>
+            <a:picLocks noChangeAspect="1"/>
+          </p:cNvPicPr>
+          <p:nvPr/>
+        </p:nvPicPr>
+        <p:blipFill>
+          <a:blip r:embed="rId4">
+            <a:extLst>
+              <a:ext uri="{28A0092B-C50C-407E-A947-70E740481C1C}">
+                <a14:useLocalDpi xmlns:a14="http://schemas.microsoft.com/office/drawing/2010/main" val="0"/>
+              </a:ext>
+            </a:extLst>
+          </a:blip>
+          <a:srcRect l="1914" t="44598" r="28206" b="1098"/>
+          <a:stretch/>
+        </p:blipFill>
+        <p:spPr>
+          <a:xfrm>
+            <a:off x="5537877" y="2809936"/>
+            <a:ext cx="5250721" cy="2043396"/>
+          </a:xfrm>
+          <a:prstGeom prst="rect">
+            <a:avLst/>
+          </a:prstGeom>
+        </p:spPr>
+      </p:pic>
+      <p:sp>
+        <p:nvSpPr>
+          <p:cNvPr id="23" name="Textfeld 22">
+            <a:extLst>
+              <a:ext uri="{FF2B5EF4-FFF2-40B4-BE49-F238E27FC236}">
+                <a16:creationId xmlns:a16="http://schemas.microsoft.com/office/drawing/2014/main" id="{CFA7B5D4-1170-5B1A-34C9-2C23E6931527}"/>
+              </a:ext>
+            </a:extLst>
+          </p:cNvPr>
+          <p:cNvSpPr txBox="1"/>
+          <p:nvPr/>
+        </p:nvSpPr>
+        <p:spPr>
+          <a:xfrm>
+            <a:off x="5537877" y="4840213"/>
+            <a:ext cx="5250721" cy="477054"/>
+          </a:xfrm>
+          <a:prstGeom prst="rect">
+            <a:avLst/>
+          </a:prstGeom>
+          <a:noFill/>
+        </p:spPr>
+        <p:txBody>
+          <a:bodyPr wrap="square" rtlCol="0">
+            <a:spAutoFit/>
+          </a:bodyPr>
+          <a:lstStyle/>
+          <a:p>
+            <a:pPr algn="ctr"/>
+            <a:r>
+              <a:rPr lang="de-DE" sz="2500" dirty="0">
+                <a:latin typeface="Times New Roman" panose="02020603050405020304" pitchFamily="18" charset="0"/>
+                <a:cs typeface="Times New Roman" panose="02020603050405020304" pitchFamily="18" charset="0"/>
+              </a:rPr>
+              <a:t>(d) Pos. Coupling Fundamental</a:t>
+            </a:r>
+          </a:p>
+        </p:txBody>
+      </p:sp>
+      <p:pic>
+        <p:nvPicPr>
+          <p:cNvPr id="24" name="Grafik 23" descr="Ein Bild, das Farbigkeit, Diagramm, Screenshot, Grafiken enthält.&#10;&#10;KI-generierte Inhalte können fehlerhaft sein.">
+            <a:extLst>
+              <a:ext uri="{FF2B5EF4-FFF2-40B4-BE49-F238E27FC236}">
+                <a16:creationId xmlns:a16="http://schemas.microsoft.com/office/drawing/2014/main" id="{6F4BA41F-53CF-8E58-6EAB-4CD13A73015C}"/>
+              </a:ext>
+            </a:extLst>
+          </p:cNvPr>
+          <p:cNvPicPr>
+            <a:picLocks noChangeAspect="1"/>
+          </p:cNvPicPr>
+          <p:nvPr/>
+        </p:nvPicPr>
+        <p:blipFill>
+          <a:blip r:embed="rId5">
+            <a:extLst>
+              <a:ext uri="{28A0092B-C50C-407E-A947-70E740481C1C}">
+                <a14:useLocalDpi xmlns:a14="http://schemas.microsoft.com/office/drawing/2010/main" val="0"/>
+              </a:ext>
+            </a:extLst>
+          </a:blip>
+          <a:srcRect l="1857" t="44493" r="28263" b="1290"/>
+          <a:stretch/>
+        </p:blipFill>
+        <p:spPr>
+          <a:xfrm>
+            <a:off x="5537877" y="144621"/>
+            <a:ext cx="5259948" cy="2046987"/>
+          </a:xfrm>
+          <a:prstGeom prst="rect">
+            <a:avLst/>
+          </a:prstGeom>
+        </p:spPr>
+      </p:pic>
+      <p:sp>
+        <p:nvSpPr>
+          <p:cNvPr id="25" name="Textfeld 24">
+            <a:extLst>
+              <a:ext uri="{FF2B5EF4-FFF2-40B4-BE49-F238E27FC236}">
+                <a16:creationId xmlns:a16="http://schemas.microsoft.com/office/drawing/2014/main" id="{FAC27945-6F0A-0F34-ED7C-351F4433CB92}"/>
+              </a:ext>
+            </a:extLst>
+          </p:cNvPr>
+          <p:cNvSpPr txBox="1"/>
+          <p:nvPr/>
+        </p:nvSpPr>
+        <p:spPr>
+          <a:xfrm>
+            <a:off x="5537878" y="2191608"/>
+            <a:ext cx="5250720" cy="477054"/>
+          </a:xfrm>
+          <a:prstGeom prst="rect">
+            <a:avLst/>
+          </a:prstGeom>
+          <a:noFill/>
+        </p:spPr>
+        <p:txBody>
+          <a:bodyPr wrap="square" rtlCol="0">
+            <a:spAutoFit/>
+          </a:bodyPr>
+          <a:lstStyle/>
+          <a:p>
+            <a:pPr algn="ctr"/>
+            <a:r>
+              <a:rPr lang="de-DE" sz="2500" dirty="0">
+                <a:latin typeface="Times New Roman" panose="02020603050405020304" pitchFamily="18" charset="0"/>
+                <a:cs typeface="Times New Roman" panose="02020603050405020304" pitchFamily="18" charset="0"/>
+              </a:rPr>
+              <a:t>(b) Pos. Coupling DC</a:t>
+            </a:r>
+          </a:p>
+        </p:txBody>
+      </p:sp>
+    </p:spTree>
+    <p:extLst>
+      <p:ext uri="{BB962C8B-B14F-4D97-AF65-F5344CB8AC3E}">
+        <p14:creationId xmlns:p14="http://schemas.microsoft.com/office/powerpoint/2010/main" val="1263921761"/>
       </p:ext>
     </p:extLst>
   </p:cSld>

</xml_diff>